<commit_message>
Rückmeldung Teil 1 umgesetzt (A, B, C)
- B: Zeilenzahlen beschriftet (215,48 Mio. roh gemessen vs. 210 Mio. hochgerechnet),
  ER-Diagramm um ingest_log, analyse_halt, analyse_stunde ergänzt, 0..1 zur Station,
  Umlaute in storage_evaluation.md und quellenprofil_istdaten.md, README Rohdatenzugang
- C: Kommentare in analyse.py, transform.py, ingest_wetter.py, load_paket_b.py,
  Folien mit Komma, H1-Abstufung, H2/H3 relativ, Limitationen (47 Haltestellen ab
  ca. 1000 m, Ausfälle), Fusszeile 27.10., README ohne Windows-Pfad
- A: Hinweis zu H1 und Schnee auf Folie und im Konzept (Schneehöhe statt Schneefall)
- Folien und Gesamtpräsentation neu erzeugt

Co-Authored-By: Claude Opus 5.5 <noreply@anthropic.com>
Claude-Session: https://claude.ai/code/session_01M79Fp5KSK9i1dn7LtTBPHd
</commit_message>
<xml_diff>
--- a/docs/präsentation/folien_paket_a.pptx
+++ b/docs/präsentation/folien_paket_a.pptx
@@ -719,7 +719,7 @@
           <a:lstStyle/>
           <a:p>
             <a:r>
-              <a:t>Ca. 60 Sekunden. Forschungsfrage vorlesen, dann die drei Hypothesen. H1 fragt, ob es einen Effekt gibt, H2 und H3 fragen, ob er je nach Verkehrsmittel und Tageszeit unterschiedlich stark ist.</a:t>
+              <a:t>Ca. 60 Sekunden. Forschungsfrage vorlesen, dann die drei Hypothesen. H1 fragt, ob es einen Effekt gibt, H2 und H3 fragen, ob er je nach Verkehrsmittel und Tageszeit unterschiedlich stark ist. Zu H1: Der Test vergleicht starken Niederschlag mit allen übrigen Stunden. Schnee wird ergänzend nach demselben Vorgehen ausgewertet (Schneedecke oder Niederschlag bei Frost), weil SwissMetNet keinen einheitlichen Schneefall misst.</a:t>
             </a:r>
           </a:p>
         </p:txBody>
@@ -6300,6 +6300,45 @@
             </a:pPr>
             <a:r>
               <a:t>Der Effekt ist in der Hauptverkehrszeit stärker als ausserhalb.</a:t>
+            </a:r>
+          </a:p>
+        </p:txBody>
+      </p:sp>
+      <p:sp>
+        <p:nvSpPr>
+          <p:cNvPr id="16" name="TextBox 15"/>
+          <p:cNvSpPr txBox="1"/>
+          <p:nvPr/>
+        </p:nvSpPr>
+        <p:spPr>
+          <a:xfrm>
+            <a:off x="502920" y="6053328"/>
+            <a:ext cx="11155680" cy="365760"/>
+          </a:xfrm>
+          <a:prstGeom prst="rect">
+            <a:avLst/>
+          </a:prstGeom>
+          <a:noFill/>
+        </p:spPr>
+        <p:txBody>
+          <a:bodyPr wrap="square">
+            <a:spAutoFit/>
+          </a:bodyPr>
+          <a:lstStyle/>
+          <a:p>
+            <a:pPr>
+              <a:spcAft>
+                <a:spcPts val="1200"/>
+              </a:spcAft>
+              <a:defRPr sz="1400" b="0" i="0">
+                <a:solidFill>
+                  <a:srgbClr val="53616B"/>
+                </a:solidFill>
+                <a:latin typeface="Aptos"/>
+              </a:defRPr>
+            </a:pPr>
+            <a:r>
+              <a:t>H1 wird mit starkem Niederschlag getestet; Schnee/Frost läuft als ergänzende Variable mit.</a:t>
             </a:r>
           </a:p>
         </p:txBody>

</xml_diff>

<commit_message>
Paket A: H1 auf starken Niederschlag präzisiert, Folien neu erzeugt
</commit_message>
<xml_diff>
--- a/docs/präsentation/folien_paket_a.pptx
+++ b/docs/präsentation/folien_paket_a.pptx
@@ -719,7 +719,7 @@
           <a:lstStyle/>
           <a:p>
             <a:r>
-              <a:t>Ca. 60 Sekunden. Forschungsfrage vorlesen, dann die drei Hypothesen. H1 fragt, ob es einen Effekt gibt, H2 und H3 fragen, ob er je nach Verkehrsmittel und Tageszeit unterschiedlich stark ist. Zu H1: Der Test vergleicht starken Niederschlag mit allen übrigen Stunden. Schnee wird ergänzend nach demselben Vorgehen ausgewertet (Schneedecke oder Niederschlag bei Frost), weil SwissMetNet keinen einheitlichen Schneefall misst.</a:t>
+              <a:t>Ca. 60 Sekunden. Forschungsfrage vorlesen, dann die drei Hypothesen. H1 fragt, ob es einen Effekt gibt, H2 und H3 fragen, ob er je nach Verkehrsmittel und Tageszeit unterschiedlich stark ist. Zu H1: Der Test vergleicht starken Niederschlag mit allen übrigen Stunden. Schnee ist keine eigene Hypothese, er wird ergänzend nach demselben Vorgehen ausgewertet (Schneedecke oder Niederschlag bei Frost), weil SwissMetNet keinen einheitlichen Schneefall misst.</a:t>
             </a:r>
           </a:p>
         </p:txBody>
@@ -6051,7 +6051,7 @@
               </a:defRPr>
             </a:pPr>
             <a:r>
-              <a:t>Bei starkem Niederschlag oder Schnee ist die mittlere Verspätung höher als sonst.</a:t>
+              <a:t>Bei starkem Niederschlag ist die mittlere Verspätung höher als sonst.</a:t>
             </a:r>
           </a:p>
         </p:txBody>
@@ -6338,7 +6338,7 @@
               </a:defRPr>
             </a:pPr>
             <a:r>
-              <a:t>H1 wird mit starkem Niederschlag getestet; Schnee/Frost läuft als ergänzende Variable mit.</a:t>
+              <a:t>Ergänzend: Schnee/Frost (Schneedecke oder Niederschlag bei Frost), gleiches Vorgehen wie H1.</a:t>
             </a:r>
           </a:p>
         </p:txBody>

</xml_diff>

<commit_message>
Präsentation: Design zum Thema, Fragen-Folien und Termine entfernt
- src/build_design.py: Hintergründe mit Schneewolken, Hügeln, Zug und Bus
- build_praesentation.py legt das Design über alle Folien, Titelfolie ohne Fusszeile
- Folien mit möglichen Fragen entfernt
- Titelfolie: Namen nach Nachnamen, ohne Kolloquiumsdatum und Raum
- Ablauf-Folie ohne Minutenangaben, Paket B als «Datenbeschaffung und Speicherung»
- Ausblick ohne Abgabedatum Teil 2, Fusszeilen ohne Datum

Co-Authored-By: Claude Opus 5.5 <noreply@anthropic.com>
Claude-Session: https://claude.ai/code/session_01M79Fp5KSK9i1dn7LtTBPHd
</commit_message>
<xml_diff>
--- a/docs/präsentation/folien_paket_a.pptx
+++ b/docs/präsentation/folien_paket_a.pptx
@@ -509,7 +509,7 @@
           <a:lstStyle/>
           <a:p>
             <a:r>
-              <a:t>Begrüssung, Thema in einem Satz: Wir untersuchen, ob und wie stark Niederschlag, Schnee und Frost die Pünktlichkeit von Bahn und Bus in der Ostschweiz beeinflussen. Gesamtdauer des Referats: 15 Minuten, je ca. 5 Minuten pro Person.</a:t>
+              <a:t>Begrüssung, Thema in einem Satz: Wir untersuchen, ob und wie stark Niederschlag, Schnee und Frost die Pünktlichkeit von Bahn und Bus in der Ostschweiz beeinflussen. Danach stellen wir die drei Teile der Reihe nach vor.</a:t>
             </a:r>
           </a:p>
         </p:txBody>
@@ -579,7 +579,7 @@
           <a:lstStyle/>
           <a:p>
             <a:r>
-              <a:t>Ca. 30 Sekunden. Kurz den Ablauf nennen: Jede Person präsentiert einen eigenständigen Teil. Danach 7 Minuten Diskussion im Plenum.</a:t>
+              <a:t>Ca. 30 Sekunden. Kurz den Ablauf nennen: Jede Person präsentiert einen eigenständigen Teil. Danach Diskussion im Plenum.</a:t>
             </a:r>
           </a:p>
         </p:txBody>
@@ -4090,7 +4090,7 @@
               </a:defRPr>
             </a:pPr>
             <a:r>
-              <a:t>Gruppe 4 · Timon · Paket A · 27.10.2026 | Quellen: SBB AG (o. J.), Reis &amp; Housley (2022), DuckDB Foundation (2026)</a:t>
+              <a:t>Gruppe 4 · Timon · Paket A | Quellen: SBB AG (o. J.), Reis &amp; Housley (2022), DuckDB Foundation (2026)</a:t>
             </a:r>
           </a:p>
         </p:txBody>
@@ -4142,8 +4142,8 @@
         </p:nvSpPr>
         <p:spPr>
           <a:xfrm>
-            <a:off x="502920" y="1371600"/>
-            <a:ext cx="11155680" cy="457200"/>
+            <a:off x="502920" y="1188720"/>
+            <a:ext cx="6583680" cy="457200"/>
           </a:xfrm>
           <a:prstGeom prst="rect">
             <a:avLst/>
@@ -4160,7 +4160,7 @@
               <a:spcAft>
                 <a:spcPts val="1200"/>
               </a:spcAft>
-              <a:defRPr sz="2000" b="1" i="0">
+              <a:defRPr sz="1800" b="1" i="0">
                 <a:solidFill>
                   <a:srgbClr val="167D8D"/>
                 </a:solidFill>
@@ -4181,8 +4181,8 @@
         </p:nvSpPr>
         <p:spPr>
           <a:xfrm>
-            <a:off x="502920" y="2011680"/>
-            <a:ext cx="11155680" cy="2011680"/>
+            <a:off x="502920" y="1691640"/>
+            <a:ext cx="6949440" cy="2194560"/>
           </a:xfrm>
           <a:prstGeom prst="rect">
             <a:avLst/>
@@ -4197,9 +4197,9 @@
           <a:p>
             <a:pPr>
               <a:spcAft>
-                <a:spcPts val="1200"/>
-              </a:spcAft>
-              <a:defRPr sz="4600" b="1" i="0">
+                <a:spcPts val="0"/>
+              </a:spcAft>
+              <a:defRPr sz="4000" b="1" i="0">
                 <a:solidFill>
                   <a:srgbClr val="17364A"/>
                 </a:solidFill>
@@ -4220,8 +4220,8 @@
         </p:nvSpPr>
         <p:spPr>
           <a:xfrm>
-            <a:off x="502920" y="3931920"/>
-            <a:ext cx="11155680" cy="548640"/>
+            <a:off x="502920" y="3429000"/>
+            <a:ext cx="7772400" cy="548640"/>
           </a:xfrm>
           <a:prstGeom prst="rect">
             <a:avLst/>
@@ -4238,7 +4238,7 @@
               <a:spcAft>
                 <a:spcPts val="1200"/>
               </a:spcAft>
-              <a:defRPr sz="2600" b="1" i="0">
+              <a:defRPr sz="2400" b="1" i="0">
                 <a:solidFill>
                   <a:srgbClr val="167D8D"/>
                 </a:solidFill>
@@ -4259,8 +4259,8 @@
         </p:nvSpPr>
         <p:spPr>
           <a:xfrm>
-            <a:off x="502920" y="4754880"/>
-            <a:ext cx="11155680" cy="457200"/>
+            <a:off x="502920" y="4114800"/>
+            <a:ext cx="7772400" cy="457200"/>
           </a:xfrm>
           <a:prstGeom prst="rect">
             <a:avLst/>
@@ -4277,7 +4277,7 @@
               <a:spcAft>
                 <a:spcPts val="1200"/>
               </a:spcAft>
-              <a:defRPr sz="2200" b="0" i="0">
+              <a:defRPr sz="2000" b="0" i="0">
                 <a:solidFill>
                   <a:srgbClr val="17364A"/>
                 </a:solidFill>
@@ -4285,46 +4285,7 @@
               </a:defRPr>
             </a:pPr>
             <a:r>
-              <a:t>Gruppe 4: Timon, Aladin, Enis</a:t>
-            </a:r>
-          </a:p>
-        </p:txBody>
-      </p:sp>
-      <p:sp>
-        <p:nvSpPr>
-          <p:cNvPr id="9" name="TextBox 8"/>
-          <p:cNvSpPr txBox="1"/>
-          <p:nvPr/>
-        </p:nvSpPr>
-        <p:spPr>
-          <a:xfrm>
-            <a:off x="502920" y="5303520"/>
-            <a:ext cx="11155680" cy="457200"/>
-          </a:xfrm>
-          <a:prstGeom prst="rect">
-            <a:avLst/>
-          </a:prstGeom>
-          <a:noFill/>
-        </p:spPr>
-        <p:txBody>
-          <a:bodyPr wrap="square">
-            <a:spAutoFit/>
-          </a:bodyPr>
-          <a:lstStyle/>
-          <a:p>
-            <a:pPr>
-              <a:spcAft>
-                <a:spcPts val="1200"/>
-              </a:spcAft>
-              <a:defRPr sz="1800" b="0" i="0">
-                <a:solidFill>
-                  <a:srgbClr val="53616B"/>
-                </a:solidFill>
-                <a:latin typeface="Aptos"/>
-              </a:defRPr>
-            </a:pPr>
-            <a:r>
-              <a:t>Kolloquium 4. November 2026, 18:00 · Raum SW 111</a:t>
+              <a:t>Gruppe 4: Enis, Aladin, Timon Wallroth</a:t>
             </a:r>
           </a:p>
         </p:txBody>
@@ -4432,7 +4393,7 @@
               </a:defRPr>
             </a:pPr>
             <a:r>
-              <a:t>Drei Pakete, je ca. 5 Minuten</a:t>
+              <a:t>Aufbau des Referats</a:t>
             </a:r>
           </a:p>
         </p:txBody>
@@ -4471,7 +4432,7 @@
               </a:defRPr>
             </a:pPr>
             <a:r>
-              <a:t>Gruppe 4 · Timon · Paket A · 27.10.2026 | Quellen: SBB AG (o. J.), Reis &amp; Housley (2022), DuckDB Foundation (2026)</a:t>
+              <a:t>Gruppe 4 · Timon · Paket A | Quellen: SBB AG (o. J.), Reis &amp; Housley (2022), DuckDB Foundation (2026)</a:t>
             </a:r>
           </a:p>
         </p:txBody>
@@ -4801,7 +4762,7 @@
               </a:defRPr>
             </a:pPr>
             <a:r>
-              <a:t>Daten rein</a:t>
+              <a:t>Datenbeschaffung und Speicherung</a:t>
             </a:r>
           </a:p>
         </p:txBody>
@@ -5044,7 +5005,7 @@
               </a:defRPr>
             </a:pPr>
             <a:r>
-              <a:t>Danach: Fragen und Diskussion im Plenum (7 Minuten)</a:t>
+              <a:t>Danach: Fragen und Diskussion im Plenum</a:t>
             </a:r>
           </a:p>
         </p:txBody>
@@ -5191,7 +5152,7 @@
               </a:defRPr>
             </a:pPr>
             <a:r>
-              <a:t>Gruppe 4 · Timon · Paket A · 27.10.2026 | Quellen: SBB AG (o. J.), Reis &amp; Housley (2022), DuckDB Foundation (2026)</a:t>
+              <a:t>Gruppe 4 · Timon · Paket A | Quellen: SBB AG (o. J.), Reis &amp; Housley (2022), DuckDB Foundation (2026)</a:t>
             </a:r>
           </a:p>
         </p:txBody>
@@ -5849,7 +5810,7 @@
               </a:defRPr>
             </a:pPr>
             <a:r>
-              <a:t>Gruppe 4 · Timon · Paket A · 27.10.2026 | Quellen: SBB AG (o. J.), Reis &amp; Housley (2022), DuckDB Foundation (2026)</a:t>
+              <a:t>Gruppe 4 · Timon · Paket A | Quellen: SBB AG (o. J.), Reis &amp; Housley (2022), DuckDB Foundation (2026)</a:t>
             </a:r>
           </a:p>
         </p:txBody>
@@ -6485,7 +6446,7 @@
               </a:defRPr>
             </a:pPr>
             <a:r>
-              <a:t>Gruppe 4 · Timon · Paket A · 27.10.2026 | Quellen: SBB AG (o. J.), Reis &amp; Housley (2022), DuckDB Foundation (2026)</a:t>
+              <a:t>Gruppe 4 · Timon · Paket A | Quellen: SBB AG (o. J.), Reis &amp; Housley (2022), DuckDB Foundation (2026)</a:t>
             </a:r>
           </a:p>
         </p:txBody>
@@ -7116,7 +7077,7 @@
               </a:defRPr>
             </a:pPr>
             <a:r>
-              <a:t>Gruppe 4 · Timon · Paket A · 27.10.2026 | Quellen: SBB AG (o. J.), Reis &amp; Housley (2022), DuckDB Foundation (2026)</a:t>
+              <a:t>Gruppe 4 · Timon · Paket A | Quellen: SBB AG (o. J.), Reis &amp; Housley (2022), DuckDB Foundation (2026)</a:t>
             </a:r>
           </a:p>
         </p:txBody>
@@ -8411,7 +8372,7 @@
               </a:defRPr>
             </a:pPr>
             <a:r>
-              <a:t>Gruppe 4 · Timon · Paket A · 27.10.2026 | Quellen: SBB AG (o. J.), Reis &amp; Housley (2022), DuckDB Foundation (2026)</a:t>
+              <a:t>Gruppe 4 · Timon · Paket A | Quellen: SBB AG (o. J.), Reis &amp; Housley (2022), DuckDB Foundation (2026)</a:t>
             </a:r>
           </a:p>
         </p:txBody>
@@ -8867,7 +8828,7 @@
               </a:defRPr>
             </a:pPr>
             <a:r>
-              <a:t>Abgabe Teil 2: 8. Dezember 2026 · Fragen und Diskussion (7 Minuten)</a:t>
+              <a:t>Fragen und Diskussion</a:t>
             </a:r>
           </a:p>
         </p:txBody>
@@ -9014,7 +8975,7 @@
               </a:defRPr>
             </a:pPr>
             <a:r>
-              <a:t>Gruppe 4 · Timon · Paket A · 27.10.2026 | Quellen: SBB AG (o. J.), Reis &amp; Housley (2022), DuckDB Foundation (2026)</a:t>
+              <a:t>Gruppe 4 · Timon · Paket A | Quellen: SBB AG (o. J.), Reis &amp; Housley (2022), DuckDB Foundation (2026)</a:t>
             </a:r>
           </a:p>
         </p:txBody>

</xml_diff>